<commit_message>
added the copilot section
</commit_message>
<xml_diff>
--- a/Project/slides/CMSC-4200-Group1-Project.pptx
+++ b/Project/slides/CMSC-4200-Group1-Project.pptx
@@ -16,8 +16,8 @@
     <p:sldId id="281" r:id="rId7"/>
     <p:sldId id="264" r:id="rId8"/>
     <p:sldId id="279" r:id="rId9"/>
-    <p:sldId id="265" r:id="rId10"/>
-    <p:sldId id="280" r:id="rId11"/>
+    <p:sldId id="282" r:id="rId10"/>
+    <p:sldId id="283" r:id="rId11"/>
     <p:sldId id="266" r:id="rId12"/>
     <p:sldId id="267" r:id="rId13"/>
     <p:sldId id="268" r:id="rId14"/>
@@ -133,7 +133,7 @@
 <file path=ppt/revisionInfo.xml><?xml version="1.0" encoding="utf-8"?>
 <p1510:revInfo xmlns:a="http://schemas.openxmlformats.org/drawingml/2006/main" xmlns:r="http://schemas.openxmlformats.org/officeDocument/2006/relationships" xmlns:p1510="http://schemas.microsoft.com/office/powerpoint/2015/10/main">
   <p1510:revLst>
-    <p1510:client id="{CC643A21-DF86-4903-A0E1-16499DD88D78}" v="226" dt="2026-03-20T14:50:39.191"/>
+    <p1510:client id="{DFE91101-9C0C-495D-AC60-35A8310EF3A0}" v="4" dt="2026-03-28T19:04:34.220"/>
   </p1510:revLst>
 </p1510:revInfo>
 </file>
@@ -296,21 +296,6 @@
           </ac:spMkLst>
         </pc:spChg>
       </pc:sldChg>
-      <pc:sldChg chg="modSp new mod ord">
-        <pc:chgData name="Margo Bonal" userId="18c9fa0f-b53d-478b-9dc0-6ad88786c19f" providerId="ADAL" clId="{93D479E5-F67F-4B8A-A78F-A0B574A116B6}" dt="2026-03-20T14:22:28.380" v="2284"/>
-        <pc:sldMkLst>
-          <pc:docMk/>
-          <pc:sldMk cId="3330183413" sldId="265"/>
-        </pc:sldMkLst>
-        <pc:spChg chg="mod">
-          <ac:chgData name="Margo Bonal" userId="18c9fa0f-b53d-478b-9dc0-6ad88786c19f" providerId="ADAL" clId="{93D479E5-F67F-4B8A-A78F-A0B574A116B6}" dt="2026-03-14T15:47:30.346" v="345" actId="20577"/>
-          <ac:spMkLst>
-            <pc:docMk/>
-            <pc:sldMk cId="3330183413" sldId="265"/>
-            <ac:spMk id="2" creationId="{0E9721CE-7FDB-6F1E-862D-17EEEB49DF9B}"/>
-          </ac:spMkLst>
-        </pc:spChg>
-      </pc:sldChg>
       <pc:sldChg chg="addSp modSp new mod setBg">
         <pc:chgData name="Margo Bonal" userId="18c9fa0f-b53d-478b-9dc0-6ad88786c19f" providerId="ADAL" clId="{93D479E5-F67F-4B8A-A78F-A0B574A116B6}" dt="2026-03-23T15:41:42.442" v="2589" actId="26606"/>
         <pc:sldMkLst>
@@ -370,14 +355,6 @@
             <pc:docMk/>
             <pc:sldMk cId="4119443303" sldId="267"/>
             <ac:spMk id="2" creationId="{45E01E8D-68C8-D6F0-81C8-63C5F69745F8}"/>
-          </ac:spMkLst>
-        </pc:spChg>
-        <pc:spChg chg="del mod">
-          <ac:chgData name="Margo Bonal" userId="18c9fa0f-b53d-478b-9dc0-6ad88786c19f" providerId="ADAL" clId="{93D479E5-F67F-4B8A-A78F-A0B574A116B6}" dt="2026-03-23T15:43:49.810" v="2724" actId="26606"/>
-          <ac:spMkLst>
-            <pc:docMk/>
-            <pc:sldMk cId="4119443303" sldId="267"/>
-            <ac:spMk id="3" creationId="{1432174E-B03B-5BA6-1C84-A4132D40EE4A}"/>
           </ac:spMkLst>
         </pc:spChg>
         <pc:spChg chg="add">
@@ -712,21 +689,6 @@
           </ac:spMkLst>
         </pc:spChg>
       </pc:sldChg>
-      <pc:sldChg chg="modSp new mod">
-        <pc:chgData name="Margo Bonal" userId="18c9fa0f-b53d-478b-9dc0-6ad88786c19f" providerId="ADAL" clId="{93D479E5-F67F-4B8A-A78F-A0B574A116B6}" dt="2026-03-20T14:48:22.777" v="2516" actId="20577"/>
-        <pc:sldMkLst>
-          <pc:docMk/>
-          <pc:sldMk cId="1241832078" sldId="280"/>
-        </pc:sldMkLst>
-        <pc:spChg chg="mod">
-          <ac:chgData name="Margo Bonal" userId="18c9fa0f-b53d-478b-9dc0-6ad88786c19f" providerId="ADAL" clId="{93D479E5-F67F-4B8A-A78F-A0B574A116B6}" dt="2026-03-20T14:48:22.777" v="2516" actId="20577"/>
-          <ac:spMkLst>
-            <pc:docMk/>
-            <pc:sldMk cId="1241832078" sldId="280"/>
-            <ac:spMk id="2" creationId="{0323EFBA-DE92-D377-1D39-284CAE8AD33D}"/>
-          </ac:spMkLst>
-        </pc:spChg>
-      </pc:sldChg>
       <pc:sldChg chg="addSp delSp modSp add mod ord">
         <pc:chgData name="Margo Bonal" userId="18c9fa0f-b53d-478b-9dc0-6ad88786c19f" providerId="ADAL" clId="{93D479E5-F67F-4B8A-A78F-A0B574A116B6}" dt="2026-03-20T14:47:52.239" v="2496" actId="1076"/>
         <pc:sldMkLst>
@@ -749,6 +711,97 @@
             <ac:spMk id="5" creationId="{105BD97F-88FC-7D2D-6D0A-263599A3073E}"/>
           </ac:spMkLst>
         </pc:spChg>
+      </pc:sldChg>
+    </pc:docChg>
+  </pc:docChgLst>
+  <pc:docChgLst>
+    <pc:chgData name="Luke ruffing" userId="c83d55373a9d0f60" providerId="LiveId" clId="{6963CA54-E4A7-4828-84AB-93F82157D440}"/>
+    <pc:docChg chg="undo custSel addSld delSld modSld sldOrd">
+      <pc:chgData name="Luke ruffing" userId="c83d55373a9d0f60" providerId="LiveId" clId="{6963CA54-E4A7-4828-84AB-93F82157D440}" dt="2026-03-28T19:04:34.219" v="1492" actId="20578"/>
+      <pc:docMkLst>
+        <pc:docMk/>
+      </pc:docMkLst>
+      <pc:sldChg chg="modSp mod">
+        <pc:chgData name="Luke ruffing" userId="c83d55373a9d0f60" providerId="LiveId" clId="{6963CA54-E4A7-4828-84AB-93F82157D440}" dt="2026-03-28T18:21:58.414" v="1" actId="1076"/>
+        <pc:sldMkLst>
+          <pc:docMk/>
+          <pc:sldMk cId="1605171173" sldId="263"/>
+        </pc:sldMkLst>
+        <pc:spChg chg="mod">
+          <ac:chgData name="Luke ruffing" userId="c83d55373a9d0f60" providerId="LiveId" clId="{6963CA54-E4A7-4828-84AB-93F82157D440}" dt="2026-03-28T18:21:58.414" v="1" actId="1076"/>
+          <ac:spMkLst>
+            <pc:docMk/>
+            <pc:sldMk cId="1605171173" sldId="263"/>
+            <ac:spMk id="3" creationId="{10ABEB13-E101-00CE-9CC4-735B136CA6F3}"/>
+          </ac:spMkLst>
+        </pc:spChg>
+      </pc:sldChg>
+      <pc:sldChg chg="del">
+        <pc:chgData name="Luke ruffing" userId="c83d55373a9d0f60" providerId="LiveId" clId="{6963CA54-E4A7-4828-84AB-93F82157D440}" dt="2026-03-28T18:22:23.935" v="5" actId="2696"/>
+        <pc:sldMkLst>
+          <pc:docMk/>
+          <pc:sldMk cId="3330183413" sldId="265"/>
+        </pc:sldMkLst>
+      </pc:sldChg>
+      <pc:sldChg chg="del">
+        <pc:chgData name="Luke ruffing" userId="c83d55373a9d0f60" providerId="LiveId" clId="{6963CA54-E4A7-4828-84AB-93F82157D440}" dt="2026-03-28T18:59:08.471" v="1349" actId="2696"/>
+        <pc:sldMkLst>
+          <pc:docMk/>
+          <pc:sldMk cId="1241832078" sldId="280"/>
+        </pc:sldMkLst>
+      </pc:sldChg>
+      <pc:sldChg chg="modSp add mod ord">
+        <pc:chgData name="Luke ruffing" userId="c83d55373a9d0f60" providerId="LiveId" clId="{6963CA54-E4A7-4828-84AB-93F82157D440}" dt="2026-03-28T19:00:19.382" v="1385" actId="20577"/>
+        <pc:sldMkLst>
+          <pc:docMk/>
+          <pc:sldMk cId="3932995078" sldId="282"/>
+        </pc:sldMkLst>
+        <pc:spChg chg="mod">
+          <ac:chgData name="Luke ruffing" userId="c83d55373a9d0f60" providerId="LiveId" clId="{6963CA54-E4A7-4828-84AB-93F82157D440}" dt="2026-03-28T18:22:39.099" v="13" actId="1076"/>
+          <ac:spMkLst>
+            <pc:docMk/>
+            <pc:sldMk cId="3932995078" sldId="282"/>
+            <ac:spMk id="2" creationId="{A8B4F316-66AE-96F3-5B49-868141F72C72}"/>
+          </ac:spMkLst>
+        </pc:spChg>
+        <pc:spChg chg="mod">
+          <ac:chgData name="Luke ruffing" userId="c83d55373a9d0f60" providerId="LiveId" clId="{6963CA54-E4A7-4828-84AB-93F82157D440}" dt="2026-03-28T19:00:19.382" v="1385" actId="20577"/>
+          <ac:spMkLst>
+            <pc:docMk/>
+            <pc:sldMk cId="3932995078" sldId="282"/>
+            <ac:spMk id="3" creationId="{27033F78-12A5-C599-2958-D2A9138E70D2}"/>
+          </ac:spMkLst>
+        </pc:spChg>
+      </pc:sldChg>
+      <pc:sldChg chg="modSp add mod ord">
+        <pc:chgData name="Luke ruffing" userId="c83d55373a9d0f60" providerId="LiveId" clId="{6963CA54-E4A7-4828-84AB-93F82157D440}" dt="2026-03-28T19:04:34.219" v="1492" actId="20578"/>
+        <pc:sldMkLst>
+          <pc:docMk/>
+          <pc:sldMk cId="1221874192" sldId="283"/>
+        </pc:sldMkLst>
+        <pc:spChg chg="mod">
+          <ac:chgData name="Luke ruffing" userId="c83d55373a9d0f60" providerId="LiveId" clId="{6963CA54-E4A7-4828-84AB-93F82157D440}" dt="2026-03-28T18:59:17.128" v="1361" actId="20577"/>
+          <ac:spMkLst>
+            <pc:docMk/>
+            <pc:sldMk cId="1221874192" sldId="283"/>
+            <ac:spMk id="2" creationId="{94C4550D-B994-49F2-6107-33DC5C4EC652}"/>
+          </ac:spMkLst>
+        </pc:spChg>
+        <pc:spChg chg="mod">
+          <ac:chgData name="Luke ruffing" userId="c83d55373a9d0f60" providerId="LiveId" clId="{6963CA54-E4A7-4828-84AB-93F82157D440}" dt="2026-03-28T19:04:34.219" v="1492" actId="20578"/>
+          <ac:spMkLst>
+            <pc:docMk/>
+            <pc:sldMk cId="1221874192" sldId="283"/>
+            <ac:spMk id="5" creationId="{1896BEE3-697D-90C4-333C-6ABB24067F5D}"/>
+          </ac:spMkLst>
+        </pc:spChg>
+      </pc:sldChg>
+      <pc:sldChg chg="add del ord">
+        <pc:chgData name="Luke ruffing" userId="c83d55373a9d0f60" providerId="LiveId" clId="{6963CA54-E4A7-4828-84AB-93F82157D440}" dt="2026-03-28T18:58:53.766" v="1345" actId="2696"/>
+        <pc:sldMkLst>
+          <pc:docMk/>
+          <pc:sldMk cId="1525693167" sldId="283"/>
+        </pc:sldMkLst>
       </pc:sldChg>
     </pc:docChg>
   </pc:docChgLst>
@@ -10249,7 +10302,7 @@
           <a:p>
             <a:fld id="{156D597D-8B24-4838-871A-61B024263B13}" type="datetimeFigureOut">
               <a:rPr lang="en-US" smtClean="0"/>
-              <a:t>3/23/2026</a:t>
+              <a:t>3/28/2026</a:t>
             </a:fld>
             <a:endParaRPr lang="en-US" dirty="0"/>
           </a:p>
@@ -10663,7 +10716,7 @@
           <a:p>
             <a:fld id="{3CADBD16-5BFB-4D9F-9646-C75D1B53BBB6}" type="datetimeFigureOut">
               <a:rPr lang="en-US" smtClean="0"/>
-              <a:t>3/23/2026</a:t>
+              <a:t>3/28/2026</a:t>
             </a:fld>
             <a:endParaRPr lang="en-US" dirty="0"/>
           </a:p>
@@ -10861,7 +10914,7 @@
           <a:p>
             <a:fld id="{3CADBD16-5BFB-4D9F-9646-C75D1B53BBB6}" type="datetimeFigureOut">
               <a:rPr lang="en-US" smtClean="0"/>
-              <a:t>3/23/2026</a:t>
+              <a:t>3/28/2026</a:t>
             </a:fld>
             <a:endParaRPr lang="en-US" dirty="0"/>
           </a:p>
@@ -11069,7 +11122,7 @@
           <a:p>
             <a:fld id="{3CADBD16-5BFB-4D9F-9646-C75D1B53BBB6}" type="datetimeFigureOut">
               <a:rPr lang="en-US" smtClean="0"/>
-              <a:t>3/23/2026</a:t>
+              <a:t>3/28/2026</a:t>
             </a:fld>
             <a:endParaRPr lang="en-US" dirty="0"/>
           </a:p>
@@ -11267,7 +11320,7 @@
           <a:p>
             <a:fld id="{3CADBD16-5BFB-4D9F-9646-C75D1B53BBB6}" type="datetimeFigureOut">
               <a:rPr lang="en-US" smtClean="0"/>
-              <a:t>3/23/2026</a:t>
+              <a:t>3/28/2026</a:t>
             </a:fld>
             <a:endParaRPr lang="en-US" dirty="0"/>
           </a:p>
@@ -11542,7 +11595,7 @@
           <a:p>
             <a:fld id="{3CADBD16-5BFB-4D9F-9646-C75D1B53BBB6}" type="datetimeFigureOut">
               <a:rPr lang="en-US" smtClean="0"/>
-              <a:t>3/23/2026</a:t>
+              <a:t>3/28/2026</a:t>
             </a:fld>
             <a:endParaRPr lang="en-US" dirty="0"/>
           </a:p>
@@ -11807,7 +11860,7 @@
           <a:p>
             <a:fld id="{3CADBD16-5BFB-4D9F-9646-C75D1B53BBB6}" type="datetimeFigureOut">
               <a:rPr lang="en-US" smtClean="0"/>
-              <a:t>3/23/2026</a:t>
+              <a:t>3/28/2026</a:t>
             </a:fld>
             <a:endParaRPr lang="en-US" dirty="0"/>
           </a:p>
@@ -12219,7 +12272,7 @@
           <a:p>
             <a:fld id="{3CADBD16-5BFB-4D9F-9646-C75D1B53BBB6}" type="datetimeFigureOut">
               <a:rPr lang="en-US" smtClean="0"/>
-              <a:t>3/23/2026</a:t>
+              <a:t>3/28/2026</a:t>
             </a:fld>
             <a:endParaRPr lang="en-US" dirty="0"/>
           </a:p>
@@ -12360,7 +12413,7 @@
           <a:p>
             <a:fld id="{3CADBD16-5BFB-4D9F-9646-C75D1B53BBB6}" type="datetimeFigureOut">
               <a:rPr lang="en-US" smtClean="0"/>
-              <a:t>3/23/2026</a:t>
+              <a:t>3/28/2026</a:t>
             </a:fld>
             <a:endParaRPr lang="en-US" dirty="0"/>
           </a:p>
@@ -12473,7 +12526,7 @@
           <a:p>
             <a:fld id="{3CADBD16-5BFB-4D9F-9646-C75D1B53BBB6}" type="datetimeFigureOut">
               <a:rPr lang="en-US" smtClean="0"/>
-              <a:t>3/23/2026</a:t>
+              <a:t>3/28/2026</a:t>
             </a:fld>
             <a:endParaRPr lang="en-US" dirty="0"/>
           </a:p>
@@ -12784,7 +12837,7 @@
           <a:p>
             <a:fld id="{3CADBD16-5BFB-4D9F-9646-C75D1B53BBB6}" type="datetimeFigureOut">
               <a:rPr lang="en-US" smtClean="0"/>
-              <a:t>3/23/2026</a:t>
+              <a:t>3/28/2026</a:t>
             </a:fld>
             <a:endParaRPr lang="en-US" dirty="0"/>
           </a:p>
@@ -13072,7 +13125,7 @@
           <a:p>
             <a:fld id="{3CADBD16-5BFB-4D9F-9646-C75D1B53BBB6}" type="datetimeFigureOut">
               <a:rPr lang="en-US" smtClean="0"/>
-              <a:t>3/23/2026</a:t>
+              <a:t>3/28/2026</a:t>
             </a:fld>
             <a:endParaRPr lang="en-US" dirty="0"/>
           </a:p>
@@ -13314,7 +13367,7 @@
             <a:fld id="{3CADBD16-5BFB-4D9F-9646-C75D1B53BBB6}" type="datetimeFigureOut">
               <a:rPr lang="en-US" smtClean="0"/>
               <a:pPr/>
-              <a:t>3/23/2026</a:t>
+              <a:t>3/28/2026</a:t>
             </a:fld>
             <a:endParaRPr lang="en-US" dirty="0"/>
           </a:p>
@@ -14463,9 +14516,23 @@
 <file path=ppt/slides/slide10.xml><?xml version="1.0" encoding="utf-8"?>
 <p:sld xmlns:a="http://schemas.openxmlformats.org/drawingml/2006/main" xmlns:r="http://schemas.openxmlformats.org/officeDocument/2006/relationships" xmlns:p="http://schemas.openxmlformats.org/presentationml/2006/main">
   <p:cSld>
+    <p:bg>
+      <p:bgPr>
+        <a:solidFill>
+          <a:schemeClr val="bg1"/>
+        </a:solidFill>
+        <a:effectLst/>
+      </p:bgPr>
+    </p:bg>
     <p:spTree>
       <p:nvGrpSpPr>
-        <p:cNvPr id="1" name=""/>
+        <p:cNvPr id="1" name="">
+          <a:extLst>
+            <a:ext uri="{FF2B5EF4-FFF2-40B4-BE49-F238E27FC236}">
+              <a16:creationId xmlns:a16="http://schemas.microsoft.com/office/drawing/2014/main" id="{3CFACA77-6FEC-C151-677F-F0ACAD003D12}"/>
+            </a:ext>
+          </a:extLst>
+        </p:cNvPr>
         <p:cNvGrpSpPr/>
         <p:nvPr/>
       </p:nvGrpSpPr>
@@ -14477,12 +14544,314 @@
           <a:chExt cx="0" cy="0"/>
         </a:xfrm>
       </p:grpSpPr>
+      <p:sp useBgFill="1">
+        <p:nvSpPr>
+          <p:cNvPr id="20" name="Rectangle 19">
+            <a:extLst>
+              <a:ext uri="{FF2B5EF4-FFF2-40B4-BE49-F238E27FC236}">
+                <a16:creationId xmlns:a16="http://schemas.microsoft.com/office/drawing/2014/main" id="{C4AA0ADD-80A5-761A-221C-411AA183EA68}"/>
+              </a:ext>
+              <a:ext uri="{C183D7F6-B498-43B3-948B-1728B52AA6E4}">
+                <adec:decorative xmlns:adec="http://schemas.microsoft.com/office/drawing/2017/decorative" val="1"/>
+              </a:ext>
+            </a:extLst>
+          </p:cNvPr>
+          <p:cNvSpPr>
+            <a:spLocks noGrp="1" noRot="1" noChangeAspect="1" noMove="1" noResize="1" noEditPoints="1" noAdjustHandles="1" noChangeArrowheads="1" noChangeShapeType="1" noTextEdit="1"/>
+          </p:cNvSpPr>
+          <p:nvPr>
+            <p:extLst>
+              <p:ext uri="{386F3935-93C4-4BCD-93E2-E3B085C9AB24}">
+                <p16:designElem xmlns:p16="http://schemas.microsoft.com/office/powerpoint/2015/main" val="1"/>
+              </p:ext>
+            </p:extLst>
+          </p:nvPr>
+        </p:nvSpPr>
+        <p:spPr>
+          <a:xfrm>
+            <a:off x="0" y="0"/>
+            <a:ext cx="12192000" cy="6858000"/>
+          </a:xfrm>
+          <a:prstGeom prst="rect">
+            <a:avLst/>
+          </a:prstGeom>
+          <a:ln w="12700" cap="flat" cmpd="sng" algn="ctr">
+            <a:noFill/>
+            <a:prstDash val="solid"/>
+            <a:miter lim="800000"/>
+          </a:ln>
+          <a:effectLst/>
+          <a:extLst>
+            <a:ext uri="{91240B29-F687-4F45-9708-019B960494DF}">
+              <a14:hiddenLine xmlns:a14="http://schemas.microsoft.com/office/drawing/2010/main" w="12700" cap="flat" cmpd="sng" algn="ctr">
+                <a:solidFill>
+                  <a:schemeClr val="accent1">
+                    <a:shade val="50000"/>
+                  </a:schemeClr>
+                </a:solidFill>
+                <a:prstDash val="solid"/>
+                <a:miter lim="800000"/>
+              </a14:hiddenLine>
+            </a:ext>
+          </a:extLst>
+        </p:spPr>
+        <p:style>
+          <a:lnRef idx="2">
+            <a:schemeClr val="accent1">
+              <a:shade val="50000"/>
+            </a:schemeClr>
+          </a:lnRef>
+          <a:fillRef idx="1">
+            <a:schemeClr val="accent1"/>
+          </a:fillRef>
+          <a:effectRef idx="0">
+            <a:schemeClr val="accent1"/>
+          </a:effectRef>
+          <a:fontRef idx="minor">
+            <a:schemeClr val="lt1"/>
+          </a:fontRef>
+        </p:style>
+        <p:txBody>
+          <a:bodyPr rtlCol="0" anchor="ctr"/>
+          <a:lstStyle/>
+          <a:p>
+            <a:pPr algn="ctr"/>
+            <a:endParaRPr lang="en-US" dirty="0"/>
+          </a:p>
+        </p:txBody>
+      </p:sp>
+      <p:sp>
+        <p:nvSpPr>
+          <p:cNvPr id="22" name="Rectangle 21">
+            <a:extLst>
+              <a:ext uri="{FF2B5EF4-FFF2-40B4-BE49-F238E27FC236}">
+                <a16:creationId xmlns:a16="http://schemas.microsoft.com/office/drawing/2014/main" id="{DB7BB62F-B221-8ADF-FB85-68660B92112C}"/>
+              </a:ext>
+              <a:ext uri="{C183D7F6-B498-43B3-948B-1728B52AA6E4}">
+                <adec:decorative xmlns:adec="http://schemas.microsoft.com/office/drawing/2017/decorative" val="1"/>
+              </a:ext>
+            </a:extLst>
+          </p:cNvPr>
+          <p:cNvSpPr>
+            <a:spLocks noGrp="1" noRot="1" noChangeAspect="1" noMove="1" noResize="1" noEditPoints="1" noAdjustHandles="1" noChangeArrowheads="1" noChangeShapeType="1" noTextEdit="1"/>
+          </p:cNvSpPr>
+          <p:nvPr>
+            <p:extLst>
+              <p:ext uri="{386F3935-93C4-4BCD-93E2-E3B085C9AB24}">
+                <p16:designElem xmlns:p16="http://schemas.microsoft.com/office/powerpoint/2015/main" val="1"/>
+              </p:ext>
+            </p:extLst>
+          </p:nvPr>
+        </p:nvSpPr>
+        <p:spPr>
+          <a:xfrm flipH="1">
+            <a:off x="2" y="0"/>
+            <a:ext cx="12191998" cy="1575955"/>
+          </a:xfrm>
+          <a:prstGeom prst="rect">
+            <a:avLst/>
+          </a:prstGeom>
+          <a:gradFill>
+            <a:gsLst>
+              <a:gs pos="0">
+                <a:srgbClr val="000000">
+                  <a:alpha val="96000"/>
+                </a:srgbClr>
+              </a:gs>
+              <a:gs pos="100000">
+                <a:schemeClr val="accent1">
+                  <a:lumMod val="75000"/>
+                </a:schemeClr>
+              </a:gs>
+            </a:gsLst>
+            <a:lin ang="8400000" scaled="0"/>
+          </a:gradFill>
+          <a:ln>
+            <a:noFill/>
+          </a:ln>
+        </p:spPr>
+        <p:style>
+          <a:lnRef idx="2">
+            <a:schemeClr val="accent1">
+              <a:shade val="50000"/>
+            </a:schemeClr>
+          </a:lnRef>
+          <a:fillRef idx="1">
+            <a:schemeClr val="accent1"/>
+          </a:fillRef>
+          <a:effectRef idx="0">
+            <a:schemeClr val="accent1"/>
+          </a:effectRef>
+          <a:fontRef idx="minor">
+            <a:schemeClr val="lt1"/>
+          </a:fontRef>
+        </p:style>
+        <p:txBody>
+          <a:bodyPr rtlCol="0" anchor="ctr"/>
+          <a:lstStyle/>
+          <a:p>
+            <a:pPr algn="ctr"/>
+            <a:endParaRPr lang="en-US" dirty="0"/>
+          </a:p>
+        </p:txBody>
+      </p:sp>
+      <p:sp>
+        <p:nvSpPr>
+          <p:cNvPr id="24" name="Rectangle 23">
+            <a:extLst>
+              <a:ext uri="{FF2B5EF4-FFF2-40B4-BE49-F238E27FC236}">
+                <a16:creationId xmlns:a16="http://schemas.microsoft.com/office/drawing/2014/main" id="{23822C2B-B6DD-F7FF-492D-BF6B55D6FF2C}"/>
+              </a:ext>
+              <a:ext uri="{C183D7F6-B498-43B3-948B-1728B52AA6E4}">
+                <adec:decorative xmlns:adec="http://schemas.microsoft.com/office/drawing/2017/decorative" val="1"/>
+              </a:ext>
+            </a:extLst>
+          </p:cNvPr>
+          <p:cNvSpPr>
+            <a:spLocks noGrp="1" noRot="1" noChangeAspect="1" noMove="1" noResize="1" noEditPoints="1" noAdjustHandles="1" noChangeArrowheads="1" noChangeShapeType="1" noTextEdit="1"/>
+          </p:cNvSpPr>
+          <p:nvPr>
+            <p:extLst>
+              <p:ext uri="{386F3935-93C4-4BCD-93E2-E3B085C9AB24}">
+                <p16:designElem xmlns:p16="http://schemas.microsoft.com/office/powerpoint/2015/main" val="1"/>
+              </p:ext>
+            </p:extLst>
+          </p:nvPr>
+        </p:nvSpPr>
+        <p:spPr>
+          <a:xfrm rot="10800000" flipH="1">
+            <a:off x="8128857" y="0"/>
+            <a:ext cx="4063143" cy="1576412"/>
+          </a:xfrm>
+          <a:prstGeom prst="rect">
+            <a:avLst/>
+          </a:prstGeom>
+          <a:gradFill>
+            <a:gsLst>
+              <a:gs pos="19000">
+                <a:schemeClr val="accent1">
+                  <a:lumMod val="50000"/>
+                  <a:alpha val="68000"/>
+                </a:schemeClr>
+              </a:gs>
+              <a:gs pos="100000">
+                <a:schemeClr val="accent1">
+                  <a:alpha val="79000"/>
+                </a:schemeClr>
+              </a:gs>
+            </a:gsLst>
+            <a:lin ang="19200000" scaled="0"/>
+          </a:gradFill>
+          <a:ln>
+            <a:noFill/>
+          </a:ln>
+        </p:spPr>
+        <p:style>
+          <a:lnRef idx="2">
+            <a:schemeClr val="accent1">
+              <a:shade val="50000"/>
+            </a:schemeClr>
+          </a:lnRef>
+          <a:fillRef idx="1">
+            <a:schemeClr val="accent1"/>
+          </a:fillRef>
+          <a:effectRef idx="0">
+            <a:schemeClr val="accent1"/>
+          </a:effectRef>
+          <a:fontRef idx="minor">
+            <a:schemeClr val="lt1"/>
+          </a:fontRef>
+        </p:style>
+        <p:txBody>
+          <a:bodyPr rtlCol="0" anchor="ctr"/>
+          <a:lstStyle/>
+          <a:p>
+            <a:pPr algn="ctr"/>
+            <a:endParaRPr lang="en-US" dirty="0"/>
+          </a:p>
+        </p:txBody>
+      </p:sp>
+      <p:sp>
+        <p:nvSpPr>
+          <p:cNvPr id="26" name="Rectangle 25">
+            <a:extLst>
+              <a:ext uri="{FF2B5EF4-FFF2-40B4-BE49-F238E27FC236}">
+                <a16:creationId xmlns:a16="http://schemas.microsoft.com/office/drawing/2014/main" id="{4B9ED5CA-89E4-9FB0-8096-6CAFE5D85E57}"/>
+              </a:ext>
+              <a:ext uri="{C183D7F6-B498-43B3-948B-1728B52AA6E4}">
+                <adec:decorative xmlns:adec="http://schemas.microsoft.com/office/drawing/2017/decorative" val="1"/>
+              </a:ext>
+            </a:extLst>
+          </p:cNvPr>
+          <p:cNvSpPr>
+            <a:spLocks noGrp="1" noRot="1" noChangeAspect="1" noMove="1" noResize="1" noEditPoints="1" noAdjustHandles="1" noChangeArrowheads="1" noChangeShapeType="1" noTextEdit="1"/>
+          </p:cNvSpPr>
+          <p:nvPr>
+            <p:extLst>
+              <p:ext uri="{386F3935-93C4-4BCD-93E2-E3B085C9AB24}">
+                <p16:designElem xmlns:p16="http://schemas.microsoft.com/office/powerpoint/2015/main" val="1"/>
+              </p:ext>
+            </p:extLst>
+          </p:nvPr>
+        </p:nvSpPr>
+        <p:spPr>
+          <a:xfrm rot="5400000">
+            <a:off x="5307777" y="-5307778"/>
+            <a:ext cx="1576446" cy="12192002"/>
+          </a:xfrm>
+          <a:prstGeom prst="rect">
+            <a:avLst/>
+          </a:prstGeom>
+          <a:gradFill>
+            <a:gsLst>
+              <a:gs pos="23000">
+                <a:schemeClr val="accent1">
+                  <a:alpha val="0"/>
+                </a:schemeClr>
+              </a:gs>
+              <a:gs pos="99000">
+                <a:srgbClr val="000000">
+                  <a:alpha val="74000"/>
+                </a:srgbClr>
+              </a:gs>
+            </a:gsLst>
+            <a:lin ang="20400000" scaled="0"/>
+          </a:gradFill>
+          <a:ln>
+            <a:noFill/>
+          </a:ln>
+        </p:spPr>
+        <p:style>
+          <a:lnRef idx="2">
+            <a:schemeClr val="accent1">
+              <a:shade val="50000"/>
+            </a:schemeClr>
+          </a:lnRef>
+          <a:fillRef idx="1">
+            <a:schemeClr val="accent1"/>
+          </a:fillRef>
+          <a:effectRef idx="0">
+            <a:schemeClr val="accent1"/>
+          </a:effectRef>
+          <a:fontRef idx="minor">
+            <a:schemeClr val="lt1"/>
+          </a:fontRef>
+        </p:style>
+        <p:txBody>
+          <a:bodyPr rtlCol="0" anchor="ctr"/>
+          <a:lstStyle/>
+          <a:p>
+            <a:pPr algn="ctr"/>
+            <a:endParaRPr lang="en-US" dirty="0"/>
+          </a:p>
+        </p:txBody>
+      </p:sp>
       <p:sp>
         <p:nvSpPr>
           <p:cNvPr id="2" name="Title 1">
             <a:extLst>
               <a:ext uri="{FF2B5EF4-FFF2-40B4-BE49-F238E27FC236}">
-                <a16:creationId xmlns:a16="http://schemas.microsoft.com/office/drawing/2014/main" id="{0323EFBA-DE92-D377-1D39-284CAE8AD33D}"/>
+                <a16:creationId xmlns:a16="http://schemas.microsoft.com/office/drawing/2014/main" id="{94C4550D-B994-49F2-6107-33DC5C4EC652}"/>
               </a:ext>
             </a:extLst>
           </p:cNvPr>
@@ -14493,24 +14862,36 @@
             <p:ph type="title"/>
           </p:nvPr>
         </p:nvSpPr>
-        <p:spPr/>
+        <p:spPr>
+          <a:xfrm>
+            <a:off x="3724941" y="349112"/>
+            <a:ext cx="4403915" cy="877729"/>
+          </a:xfrm>
+        </p:spPr>
         <p:txBody>
-          <a:bodyPr/>
+          <a:bodyPr anchor="ctr">
+            <a:normAutofit/>
+          </a:bodyPr>
           <a:lstStyle/>
           <a:p>
+            <a:pPr algn="ctr"/>
             <a:r>
-              <a:rPr lang="en-US" dirty="0"/>
-              <a:t>Copilot Evaluation</a:t>
+              <a:rPr lang="en-US" sz="4000" dirty="0">
+                <a:solidFill>
+                  <a:schemeClr val="bg1"/>
+                </a:solidFill>
+              </a:rPr>
+              <a:t>CoPilot Evaluation</a:t>
             </a:r>
           </a:p>
         </p:txBody>
       </p:sp>
       <p:sp>
         <p:nvSpPr>
-          <p:cNvPr id="3" name="Content Placeholder 2">
+          <p:cNvPr id="5" name="Content Placeholder 5">
             <a:extLst>
               <a:ext uri="{FF2B5EF4-FFF2-40B4-BE49-F238E27FC236}">
-                <a16:creationId xmlns:a16="http://schemas.microsoft.com/office/drawing/2014/main" id="{E0EEFB2B-C76E-42C5-DEB1-1EA4A70251B6}"/>
+                <a16:creationId xmlns:a16="http://schemas.microsoft.com/office/drawing/2014/main" id="{1896BEE3-697D-90C4-333C-6ABB24067F5D}"/>
               </a:ext>
             </a:extLst>
           </p:cNvPr>
@@ -14521,19 +14902,50 @@
             <p:ph idx="1"/>
           </p:nvPr>
         </p:nvSpPr>
-        <p:spPr/>
+        <p:spPr>
+          <a:xfrm>
+            <a:off x="1019735" y="2255931"/>
+            <a:ext cx="10515600" cy="2887569"/>
+          </a:xfrm>
+        </p:spPr>
         <p:txBody>
-          <a:bodyPr/>
+          <a:bodyPr>
+            <a:normAutofit/>
+          </a:bodyPr>
           <a:lstStyle/>
           <a:p>
-            <a:endParaRPr lang="en-US"/>
+            <a:r>
+              <a:rPr lang="en-US" dirty="0"/>
+              <a:t>Successfully interpreted prompts and generated logical solutions</a:t>
+            </a:r>
+          </a:p>
+          <a:p>
+            <a:r>
+              <a:rPr lang="en-US" dirty="0"/>
+              <a:t>Breaking prompts into sections improved logic and readability</a:t>
+            </a:r>
+          </a:p>
+          <a:p>
+            <a:r>
+              <a:rPr lang="en-US" dirty="0"/>
+              <a:t>Generated sample code for some prompts</a:t>
+            </a:r>
+          </a:p>
+          <a:p>
+            <a:r>
+              <a:rPr lang="en-US" dirty="0"/>
+              <a:t>Gave mostly clear concise answers</a:t>
+            </a:r>
+          </a:p>
+          <a:p>
+            <a:endParaRPr lang="en-US" dirty="0"/>
           </a:p>
         </p:txBody>
       </p:sp>
     </p:spTree>
     <p:extLst>
       <p:ext uri="{BB962C8B-B14F-4D97-AF65-F5344CB8AC3E}">
-        <p14:creationId xmlns:p14="http://schemas.microsoft.com/office/powerpoint/2010/main" val="1241832078"/>
+        <p14:creationId xmlns:p14="http://schemas.microsoft.com/office/powerpoint/2010/main" val="1221874192"/>
       </p:ext>
     </p:extLst>
   </p:cSld>
@@ -18609,15 +19021,7 @@
             <a:pPr lvl="1"/>
             <a:r>
               <a:rPr lang="en-US" sz="1800" dirty="0"/>
-              <a:t>D</a:t>
-            </a:r>
-            <a:r>
-              <a:rPr lang="en-US" sz="1800"/>
-              <a:t>esigned </a:t>
-            </a:r>
-            <a:r>
-              <a:rPr lang="en-US" sz="1800" dirty="0"/>
-              <a:t>specifically for password storage, provide strong protection against brute force attacks, and are fast enough that hashing and verification</a:t>
+              <a:t>Designed specifically for password storage, provide strong protection against brute force attacks, and are fast enough that hashing and verification</a:t>
             </a:r>
             <a:endParaRPr lang="en-US" sz="1050" dirty="0"/>
           </a:p>
@@ -19352,9 +19756,23 @@
 <file path=ppt/slides/slide9.xml><?xml version="1.0" encoding="utf-8"?>
 <p:sld xmlns:a="http://schemas.openxmlformats.org/drawingml/2006/main" xmlns:r="http://schemas.openxmlformats.org/officeDocument/2006/relationships" xmlns:p="http://schemas.openxmlformats.org/presentationml/2006/main">
   <p:cSld>
+    <p:bg>
+      <p:bgPr>
+        <a:solidFill>
+          <a:schemeClr val="bg1"/>
+        </a:solidFill>
+        <a:effectLst/>
+      </p:bgPr>
+    </p:bg>
     <p:spTree>
       <p:nvGrpSpPr>
-        <p:cNvPr id="1" name=""/>
+        <p:cNvPr id="1" name="">
+          <a:extLst>
+            <a:ext uri="{FF2B5EF4-FFF2-40B4-BE49-F238E27FC236}">
+              <a16:creationId xmlns:a16="http://schemas.microsoft.com/office/drawing/2014/main" id="{BDB1D6C8-4F02-8724-1596-0C4A5BE0EAC0}"/>
+            </a:ext>
+          </a:extLst>
+        </p:cNvPr>
         <p:cNvGrpSpPr/>
         <p:nvPr/>
       </p:nvGrpSpPr>
@@ -19366,12 +19784,634 @@
           <a:chExt cx="0" cy="0"/>
         </a:xfrm>
       </p:grpSpPr>
+      <p:sp useBgFill="1">
+        <p:nvSpPr>
+          <p:cNvPr id="8" name="Rectangle 7">
+            <a:extLst>
+              <a:ext uri="{FF2B5EF4-FFF2-40B4-BE49-F238E27FC236}">
+                <a16:creationId xmlns:a16="http://schemas.microsoft.com/office/drawing/2014/main" id="{E413A3D1-5251-0573-87C8-17478FCC8A95}"/>
+              </a:ext>
+              <a:ext uri="{C183D7F6-B498-43B3-948B-1728B52AA6E4}">
+                <adec:decorative xmlns:adec="http://schemas.microsoft.com/office/drawing/2017/decorative" val="1"/>
+              </a:ext>
+            </a:extLst>
+          </p:cNvPr>
+          <p:cNvSpPr>
+            <a:spLocks noGrp="1" noRot="1" noChangeAspect="1" noMove="1" noResize="1" noEditPoints="1" noAdjustHandles="1" noChangeArrowheads="1" noChangeShapeType="1" noTextEdit="1"/>
+          </p:cNvSpPr>
+          <p:nvPr>
+            <p:extLst>
+              <p:ext uri="{386F3935-93C4-4BCD-93E2-E3B085C9AB24}">
+                <p16:designElem xmlns:p16="http://schemas.microsoft.com/office/powerpoint/2015/main" val="1"/>
+              </p:ext>
+            </p:extLst>
+          </p:nvPr>
+        </p:nvSpPr>
+        <p:spPr>
+          <a:xfrm>
+            <a:off x="0" y="0"/>
+            <a:ext cx="12192000" cy="6858000"/>
+          </a:xfrm>
+          <a:prstGeom prst="rect">
+            <a:avLst/>
+          </a:prstGeom>
+          <a:ln w="12700" cap="flat" cmpd="sng" algn="ctr">
+            <a:noFill/>
+            <a:prstDash val="solid"/>
+            <a:miter lim="800000"/>
+          </a:ln>
+          <a:effectLst/>
+          <a:extLst>
+            <a:ext uri="{91240B29-F687-4F45-9708-019B960494DF}">
+              <a14:hiddenLine xmlns:a14="http://schemas.microsoft.com/office/drawing/2010/main" w="12700" cap="flat" cmpd="sng" algn="ctr">
+                <a:solidFill>
+                  <a:schemeClr val="accent1">
+                    <a:shade val="50000"/>
+                  </a:schemeClr>
+                </a:solidFill>
+                <a:prstDash val="solid"/>
+                <a:miter lim="800000"/>
+              </a14:hiddenLine>
+            </a:ext>
+          </a:extLst>
+        </p:spPr>
+        <p:style>
+          <a:lnRef idx="2">
+            <a:schemeClr val="accent1">
+              <a:shade val="50000"/>
+            </a:schemeClr>
+          </a:lnRef>
+          <a:fillRef idx="1">
+            <a:schemeClr val="accent1"/>
+          </a:fillRef>
+          <a:effectRef idx="0">
+            <a:schemeClr val="accent1"/>
+          </a:effectRef>
+          <a:fontRef idx="minor">
+            <a:schemeClr val="lt1"/>
+          </a:fontRef>
+        </p:style>
+        <p:txBody>
+          <a:bodyPr rtlCol="0" anchor="ctr"/>
+          <a:lstStyle/>
+          <a:p>
+            <a:pPr algn="ctr"/>
+            <a:endParaRPr lang="en-US" dirty="0"/>
+          </a:p>
+        </p:txBody>
+      </p:sp>
+      <p:sp useBgFill="1">
+        <p:nvSpPr>
+          <p:cNvPr id="10" name="Rectangle 9">
+            <a:extLst>
+              <a:ext uri="{FF2B5EF4-FFF2-40B4-BE49-F238E27FC236}">
+                <a16:creationId xmlns:a16="http://schemas.microsoft.com/office/drawing/2014/main" id="{1C6B8CE5-AD46-8ADE-E082-E6CA886AE370}"/>
+              </a:ext>
+              <a:ext uri="{C183D7F6-B498-43B3-948B-1728B52AA6E4}">
+                <adec:decorative xmlns:adec="http://schemas.microsoft.com/office/drawing/2017/decorative" val="1"/>
+              </a:ext>
+            </a:extLst>
+          </p:cNvPr>
+          <p:cNvSpPr>
+            <a:spLocks noGrp="1" noRot="1" noChangeAspect="1" noMove="1" noResize="1" noEditPoints="1" noAdjustHandles="1" noChangeArrowheads="1" noChangeShapeType="1" noTextEdit="1"/>
+          </p:cNvSpPr>
+          <p:nvPr>
+            <p:extLst>
+              <p:ext uri="{386F3935-93C4-4BCD-93E2-E3B085C9AB24}">
+                <p16:designElem xmlns:p16="http://schemas.microsoft.com/office/powerpoint/2015/main" val="1"/>
+              </p:ext>
+            </p:extLst>
+          </p:nvPr>
+        </p:nvSpPr>
+        <p:spPr>
+          <a:xfrm>
+            <a:off x="0" y="0"/>
+            <a:ext cx="12188952" cy="6858000"/>
+          </a:xfrm>
+          <a:prstGeom prst="rect">
+            <a:avLst/>
+          </a:prstGeom>
+          <a:ln w="12700" cap="flat" cmpd="sng" algn="ctr">
+            <a:noFill/>
+            <a:prstDash val="solid"/>
+            <a:miter lim="800000"/>
+          </a:ln>
+          <a:effectLst/>
+          <a:extLst>
+            <a:ext uri="{91240B29-F687-4F45-9708-019B960494DF}">
+              <a14:hiddenLine xmlns:a14="http://schemas.microsoft.com/office/drawing/2010/main" w="12700" cap="flat" cmpd="sng" algn="ctr">
+                <a:solidFill>
+                  <a:schemeClr val="accent1">
+                    <a:shade val="50000"/>
+                  </a:schemeClr>
+                </a:solidFill>
+                <a:prstDash val="solid"/>
+                <a:miter lim="800000"/>
+              </a14:hiddenLine>
+            </a:ext>
+          </a:extLst>
+        </p:spPr>
+        <p:style>
+          <a:lnRef idx="2">
+            <a:schemeClr val="accent1">
+              <a:shade val="50000"/>
+            </a:schemeClr>
+          </a:lnRef>
+          <a:fillRef idx="1">
+            <a:schemeClr val="accent1"/>
+          </a:fillRef>
+          <a:effectRef idx="0">
+            <a:schemeClr val="accent1"/>
+          </a:effectRef>
+          <a:fontRef idx="minor">
+            <a:schemeClr val="lt1"/>
+          </a:fontRef>
+        </p:style>
+        <p:txBody>
+          <a:bodyPr rtlCol="0" anchor="ctr"/>
+          <a:lstStyle/>
+          <a:p>
+            <a:pPr algn="ctr"/>
+            <a:endParaRPr lang="en-US" dirty="0"/>
+          </a:p>
+        </p:txBody>
+      </p:sp>
+      <p:sp>
+        <p:nvSpPr>
+          <p:cNvPr id="12" name="Rectangle 11">
+            <a:extLst>
+              <a:ext uri="{FF2B5EF4-FFF2-40B4-BE49-F238E27FC236}">
+                <a16:creationId xmlns:a16="http://schemas.microsoft.com/office/drawing/2014/main" id="{DC27483D-C8FB-34A1-A021-2481637C6016}"/>
+              </a:ext>
+              <a:ext uri="{C183D7F6-B498-43B3-948B-1728B52AA6E4}">
+                <adec:decorative xmlns:adec="http://schemas.microsoft.com/office/drawing/2017/decorative" val="1"/>
+              </a:ext>
+            </a:extLst>
+          </p:cNvPr>
+          <p:cNvSpPr>
+            <a:spLocks noGrp="1" noRot="1" noChangeAspect="1" noMove="1" noResize="1" noEditPoints="1" noAdjustHandles="1" noChangeArrowheads="1" noChangeShapeType="1" noTextEdit="1"/>
+          </p:cNvSpPr>
+          <p:nvPr>
+            <p:extLst>
+              <p:ext uri="{386F3935-93C4-4BCD-93E2-E3B085C9AB24}">
+                <p16:designElem xmlns:p16="http://schemas.microsoft.com/office/powerpoint/2015/main" val="1"/>
+              </p:ext>
+            </p:extLst>
+          </p:nvPr>
+        </p:nvSpPr>
+        <p:spPr>
+          <a:xfrm rot="5400000" flipH="1">
+            <a:off x="-1410084" y="1410082"/>
+            <a:ext cx="6858000" cy="4037836"/>
+          </a:xfrm>
+          <a:prstGeom prst="rect">
+            <a:avLst/>
+          </a:prstGeom>
+          <a:gradFill>
+            <a:gsLst>
+              <a:gs pos="8000">
+                <a:srgbClr val="000000"/>
+              </a:gs>
+              <a:gs pos="100000">
+                <a:schemeClr val="accent1">
+                  <a:lumMod val="75000"/>
+                </a:schemeClr>
+              </a:gs>
+            </a:gsLst>
+            <a:lin ang="3000000" scaled="0"/>
+          </a:gradFill>
+          <a:ln>
+            <a:noFill/>
+          </a:ln>
+        </p:spPr>
+        <p:style>
+          <a:lnRef idx="2">
+            <a:schemeClr val="accent1">
+              <a:shade val="50000"/>
+            </a:schemeClr>
+          </a:lnRef>
+          <a:fillRef idx="1">
+            <a:schemeClr val="accent1"/>
+          </a:fillRef>
+          <a:effectRef idx="0">
+            <a:schemeClr val="accent1"/>
+          </a:effectRef>
+          <a:fontRef idx="minor">
+            <a:schemeClr val="lt1"/>
+          </a:fontRef>
+        </p:style>
+        <p:txBody>
+          <a:bodyPr rtlCol="0" anchor="ctr"/>
+          <a:lstStyle/>
+          <a:p>
+            <a:pPr algn="ctr"/>
+            <a:endParaRPr lang="en-US" dirty="0"/>
+          </a:p>
+        </p:txBody>
+      </p:sp>
+      <p:sp>
+        <p:nvSpPr>
+          <p:cNvPr id="14" name="Rectangle 13">
+            <a:extLst>
+              <a:ext uri="{FF2B5EF4-FFF2-40B4-BE49-F238E27FC236}">
+                <a16:creationId xmlns:a16="http://schemas.microsoft.com/office/drawing/2014/main" id="{8356F12B-B05F-6F3B-8F6E-ABE154AD27AD}"/>
+              </a:ext>
+              <a:ext uri="{C183D7F6-B498-43B3-948B-1728B52AA6E4}">
+                <adec:decorative xmlns:adec="http://schemas.microsoft.com/office/drawing/2017/decorative" val="1"/>
+              </a:ext>
+            </a:extLst>
+          </p:cNvPr>
+          <p:cNvSpPr>
+            <a:spLocks noGrp="1" noRot="1" noChangeAspect="1" noMove="1" noResize="1" noEditPoints="1" noAdjustHandles="1" noChangeArrowheads="1" noChangeShapeType="1" noTextEdit="1"/>
+          </p:cNvSpPr>
+          <p:nvPr>
+            <p:extLst>
+              <p:ext uri="{386F3935-93C4-4BCD-93E2-E3B085C9AB24}">
+                <p16:designElem xmlns:p16="http://schemas.microsoft.com/office/powerpoint/2015/main" val="1"/>
+              </p:ext>
+            </p:extLst>
+          </p:nvPr>
+        </p:nvSpPr>
+        <p:spPr>
+          <a:xfrm rot="5400000" flipH="1">
+            <a:off x="-1410085" y="1420219"/>
+            <a:ext cx="6857999" cy="4037839"/>
+          </a:xfrm>
+          <a:prstGeom prst="rect">
+            <a:avLst/>
+          </a:prstGeom>
+          <a:gradFill>
+            <a:gsLst>
+              <a:gs pos="0">
+                <a:srgbClr val="000000">
+                  <a:alpha val="0"/>
+                </a:srgbClr>
+              </a:gs>
+              <a:gs pos="99000">
+                <a:schemeClr val="accent1">
+                  <a:alpha val="46000"/>
+                </a:schemeClr>
+              </a:gs>
+            </a:gsLst>
+            <a:lin ang="1800000" scaled="0"/>
+          </a:gradFill>
+          <a:ln>
+            <a:noFill/>
+          </a:ln>
+        </p:spPr>
+        <p:style>
+          <a:lnRef idx="2">
+            <a:schemeClr val="accent1">
+              <a:shade val="50000"/>
+            </a:schemeClr>
+          </a:lnRef>
+          <a:fillRef idx="1">
+            <a:schemeClr val="accent1"/>
+          </a:fillRef>
+          <a:effectRef idx="0">
+            <a:schemeClr val="accent1"/>
+          </a:effectRef>
+          <a:fontRef idx="minor">
+            <a:schemeClr val="lt1"/>
+          </a:fontRef>
+        </p:style>
+        <p:txBody>
+          <a:bodyPr rtlCol="0" anchor="ctr"/>
+          <a:lstStyle/>
+          <a:p>
+            <a:pPr algn="ctr"/>
+            <a:endParaRPr lang="en-US" dirty="0"/>
+          </a:p>
+        </p:txBody>
+      </p:sp>
+      <p:sp>
+        <p:nvSpPr>
+          <p:cNvPr id="16" name="Rectangle 15">
+            <a:extLst>
+              <a:ext uri="{FF2B5EF4-FFF2-40B4-BE49-F238E27FC236}">
+                <a16:creationId xmlns:a16="http://schemas.microsoft.com/office/drawing/2014/main" id="{DDFF7ADA-4E82-9612-4783-2821CC2EB086}"/>
+              </a:ext>
+              <a:ext uri="{C183D7F6-B498-43B3-948B-1728B52AA6E4}">
+                <adec:decorative xmlns:adec="http://schemas.microsoft.com/office/drawing/2017/decorative" val="1"/>
+              </a:ext>
+            </a:extLst>
+          </p:cNvPr>
+          <p:cNvSpPr>
+            <a:spLocks noGrp="1" noRot="1" noChangeAspect="1" noMove="1" noResize="1" noEditPoints="1" noAdjustHandles="1" noChangeArrowheads="1" noChangeShapeType="1" noTextEdit="1"/>
+          </p:cNvSpPr>
+          <p:nvPr>
+            <p:extLst>
+              <p:ext uri="{386F3935-93C4-4BCD-93E2-E3B085C9AB24}">
+                <p16:designElem xmlns:p16="http://schemas.microsoft.com/office/powerpoint/2015/main" val="1"/>
+              </p:ext>
+            </p:extLst>
+          </p:nvPr>
+        </p:nvSpPr>
+        <p:spPr>
+          <a:xfrm rot="5400000" flipH="1">
+            <a:off x="767923" y="3588085"/>
+            <a:ext cx="2501979" cy="4037841"/>
+          </a:xfrm>
+          <a:prstGeom prst="rect">
+            <a:avLst/>
+          </a:prstGeom>
+          <a:gradFill>
+            <a:gsLst>
+              <a:gs pos="2000">
+                <a:schemeClr val="accent1">
+                  <a:alpha val="29000"/>
+                </a:schemeClr>
+              </a:gs>
+              <a:gs pos="100000">
+                <a:srgbClr val="000000">
+                  <a:alpha val="30000"/>
+                </a:srgbClr>
+              </a:gs>
+            </a:gsLst>
+            <a:lin ang="7800000" scaled="0"/>
+          </a:gradFill>
+          <a:ln>
+            <a:noFill/>
+          </a:ln>
+        </p:spPr>
+        <p:style>
+          <a:lnRef idx="2">
+            <a:schemeClr val="accent1">
+              <a:shade val="50000"/>
+            </a:schemeClr>
+          </a:lnRef>
+          <a:fillRef idx="1">
+            <a:schemeClr val="accent1"/>
+          </a:fillRef>
+          <a:effectRef idx="0">
+            <a:schemeClr val="accent1"/>
+          </a:effectRef>
+          <a:fontRef idx="minor">
+            <a:schemeClr val="lt1"/>
+          </a:fontRef>
+        </p:style>
+        <p:txBody>
+          <a:bodyPr rtlCol="0" anchor="ctr"/>
+          <a:lstStyle/>
+          <a:p>
+            <a:pPr algn="ctr"/>
+            <a:endParaRPr lang="en-US" dirty="0"/>
+          </a:p>
+        </p:txBody>
+      </p:sp>
+      <p:sp>
+        <p:nvSpPr>
+          <p:cNvPr id="18" name="Freeform: Shape 17">
+            <a:extLst>
+              <a:ext uri="{FF2B5EF4-FFF2-40B4-BE49-F238E27FC236}">
+                <a16:creationId xmlns:a16="http://schemas.microsoft.com/office/drawing/2014/main" id="{9B8E3684-C082-4A54-A45A-435EE5380F3B}"/>
+              </a:ext>
+              <a:ext uri="{C183D7F6-B498-43B3-948B-1728B52AA6E4}">
+                <adec:decorative xmlns:adec="http://schemas.microsoft.com/office/drawing/2017/decorative" val="1"/>
+              </a:ext>
+            </a:extLst>
+          </p:cNvPr>
+          <p:cNvSpPr>
+            <a:spLocks noGrp="1" noRot="1" noChangeAspect="1" noMove="1" noResize="1" noEditPoints="1" noAdjustHandles="1" noChangeArrowheads="1" noChangeShapeType="1" noTextEdit="1"/>
+          </p:cNvSpPr>
+          <p:nvPr>
+            <p:extLst>
+              <p:ext uri="{386F3935-93C4-4BCD-93E2-E3B085C9AB24}">
+                <p16:designElem xmlns:p16="http://schemas.microsoft.com/office/powerpoint/2015/main" val="1"/>
+              </p:ext>
+            </p:extLst>
+          </p:nvPr>
+        </p:nvSpPr>
+        <p:spPr>
+          <a:xfrm rot="20635413">
+            <a:off x="-501737" y="969718"/>
+            <a:ext cx="3900357" cy="4178958"/>
+          </a:xfrm>
+          <a:custGeom>
+            <a:avLst/>
+            <a:gdLst>
+              <a:gd name="connsiteX0" fmla="*/ 2432225 w 3900357"/>
+              <a:gd name="connsiteY0" fmla="*/ 93939 h 4178958"/>
+              <a:gd name="connsiteX1" fmla="*/ 3900357 w 3900357"/>
+              <a:gd name="connsiteY1" fmla="*/ 2089479 h 4178958"/>
+              <a:gd name="connsiteX2" fmla="*/ 1810878 w 3900357"/>
+              <a:gd name="connsiteY2" fmla="*/ 4178958 h 4178958"/>
+              <a:gd name="connsiteX3" fmla="*/ 78249 w 3900357"/>
+              <a:gd name="connsiteY3" fmla="*/ 3257727 h 4178958"/>
+              <a:gd name="connsiteX4" fmla="*/ 0 w 3900357"/>
+              <a:gd name="connsiteY4" fmla="*/ 3128923 h 4178958"/>
+              <a:gd name="connsiteX5" fmla="*/ 831324 w 3900357"/>
+              <a:gd name="connsiteY5" fmla="*/ 244281 h 4178958"/>
+              <a:gd name="connsiteX6" fmla="*/ 997559 w 3900357"/>
+              <a:gd name="connsiteY6" fmla="*/ 164202 h 4178958"/>
+              <a:gd name="connsiteX7" fmla="*/ 1810878 w 3900357"/>
+              <a:gd name="connsiteY7" fmla="*/ 0 h 4178958"/>
+              <a:gd name="connsiteX8" fmla="*/ 2432225 w 3900357"/>
+              <a:gd name="connsiteY8" fmla="*/ 93939 h 4178958"/>
+            </a:gdLst>
+            <a:ahLst/>
+            <a:cxnLst>
+              <a:cxn ang="0">
+                <a:pos x="connsiteX0" y="connsiteY0"/>
+              </a:cxn>
+              <a:cxn ang="0">
+                <a:pos x="connsiteX1" y="connsiteY1"/>
+              </a:cxn>
+              <a:cxn ang="0">
+                <a:pos x="connsiteX2" y="connsiteY2"/>
+              </a:cxn>
+              <a:cxn ang="0">
+                <a:pos x="connsiteX3" y="connsiteY3"/>
+              </a:cxn>
+              <a:cxn ang="0">
+                <a:pos x="connsiteX4" y="connsiteY4"/>
+              </a:cxn>
+              <a:cxn ang="0">
+                <a:pos x="connsiteX5" y="connsiteY5"/>
+              </a:cxn>
+              <a:cxn ang="0">
+                <a:pos x="connsiteX6" y="connsiteY6"/>
+              </a:cxn>
+              <a:cxn ang="0">
+                <a:pos x="connsiteX7" y="connsiteY7"/>
+              </a:cxn>
+              <a:cxn ang="0">
+                <a:pos x="connsiteX8" y="connsiteY8"/>
+              </a:cxn>
+            </a:cxnLst>
+            <a:rect l="l" t="t" r="r" b="b"/>
+            <a:pathLst>
+              <a:path w="3900357" h="4178958">
+                <a:moveTo>
+                  <a:pt x="2432225" y="93939"/>
+                </a:moveTo>
+                <a:cubicBezTo>
+                  <a:pt x="3282786" y="358491"/>
+                  <a:pt x="3900357" y="1151865"/>
+                  <a:pt x="3900357" y="2089479"/>
+                </a:cubicBezTo>
+                <a:cubicBezTo>
+                  <a:pt x="3900357" y="3243466"/>
+                  <a:pt x="2964865" y="4178958"/>
+                  <a:pt x="1810878" y="4178958"/>
+                </a:cubicBezTo>
+                <a:cubicBezTo>
+                  <a:pt x="1089636" y="4178958"/>
+                  <a:pt x="453744" y="3813531"/>
+                  <a:pt x="78249" y="3257727"/>
+                </a:cubicBezTo>
+                <a:lnTo>
+                  <a:pt x="0" y="3128923"/>
+                </a:lnTo>
+                <a:lnTo>
+                  <a:pt x="831324" y="244281"/>
+                </a:lnTo>
+                <a:lnTo>
+                  <a:pt x="997559" y="164202"/>
+                </a:lnTo>
+                <a:cubicBezTo>
+                  <a:pt x="1247540" y="58468"/>
+                  <a:pt x="1522381" y="0"/>
+                  <a:pt x="1810878" y="0"/>
+                </a:cubicBezTo>
+                <a:cubicBezTo>
+                  <a:pt x="2027251" y="0"/>
+                  <a:pt x="2235942" y="32888"/>
+                  <a:pt x="2432225" y="93939"/>
+                </a:cubicBezTo>
+                <a:close/>
+              </a:path>
+            </a:pathLst>
+          </a:custGeom>
+          <a:gradFill>
+            <a:gsLst>
+              <a:gs pos="29000">
+                <a:srgbClr val="000000">
+                  <a:alpha val="0"/>
+                </a:srgbClr>
+              </a:gs>
+              <a:gs pos="100000">
+                <a:schemeClr val="accent1">
+                  <a:alpha val="43000"/>
+                </a:schemeClr>
+              </a:gs>
+            </a:gsLst>
+            <a:lin ang="1800000" scaled="0"/>
+          </a:gradFill>
+          <a:ln>
+            <a:noFill/>
+          </a:ln>
+        </p:spPr>
+        <p:style>
+          <a:lnRef idx="2">
+            <a:schemeClr val="accent1">
+              <a:shade val="50000"/>
+            </a:schemeClr>
+          </a:lnRef>
+          <a:fillRef idx="1">
+            <a:schemeClr val="accent1"/>
+          </a:fillRef>
+          <a:effectRef idx="0">
+            <a:schemeClr val="accent1"/>
+          </a:effectRef>
+          <a:fontRef idx="minor">
+            <a:schemeClr val="lt1"/>
+          </a:fontRef>
+        </p:style>
+        <p:txBody>
+          <a:bodyPr wrap="square" rtlCol="0" anchor="ctr">
+            <a:noAutofit/>
+          </a:bodyPr>
+          <a:lstStyle/>
+          <a:p>
+            <a:pPr algn="ctr"/>
+            <a:endParaRPr lang="en-US" dirty="0"/>
+          </a:p>
+        </p:txBody>
+      </p:sp>
+      <p:sp>
+        <p:nvSpPr>
+          <p:cNvPr id="20" name="Rectangle 19">
+            <a:extLst>
+              <a:ext uri="{FF2B5EF4-FFF2-40B4-BE49-F238E27FC236}">
+                <a16:creationId xmlns:a16="http://schemas.microsoft.com/office/drawing/2014/main" id="{27FCB3E1-5046-0D6D-E9DB-85D3A20161CD}"/>
+              </a:ext>
+              <a:ext uri="{C183D7F6-B498-43B3-948B-1728B52AA6E4}">
+                <adec:decorative xmlns:adec="http://schemas.microsoft.com/office/drawing/2017/decorative" val="1"/>
+              </a:ext>
+            </a:extLst>
+          </p:cNvPr>
+          <p:cNvSpPr>
+            <a:spLocks noGrp="1" noRot="1" noChangeAspect="1" noMove="1" noResize="1" noEditPoints="1" noAdjustHandles="1" noChangeArrowheads="1" noChangeShapeType="1" noTextEdit="1"/>
+          </p:cNvSpPr>
+          <p:nvPr>
+            <p:extLst>
+              <p:ext uri="{386F3935-93C4-4BCD-93E2-E3B085C9AB24}">
+                <p16:designElem xmlns:p16="http://schemas.microsoft.com/office/powerpoint/2015/main" val="1"/>
+              </p:ext>
+            </p:extLst>
+          </p:nvPr>
+        </p:nvSpPr>
+        <p:spPr>
+          <a:xfrm rot="5400000" flipH="1">
+            <a:off x="-1410093" y="1399943"/>
+            <a:ext cx="6858003" cy="4037835"/>
+          </a:xfrm>
+          <a:prstGeom prst="rect">
+            <a:avLst/>
+          </a:prstGeom>
+          <a:gradFill>
+            <a:gsLst>
+              <a:gs pos="0">
+                <a:srgbClr val="000000">
+                  <a:alpha val="0"/>
+                </a:srgbClr>
+              </a:gs>
+              <a:gs pos="99000">
+                <a:schemeClr val="accent1">
+                  <a:lumMod val="60000"/>
+                  <a:lumOff val="40000"/>
+                  <a:alpha val="11000"/>
+                </a:schemeClr>
+              </a:gs>
+            </a:gsLst>
+            <a:lin ang="7200000" scaled="0"/>
+          </a:gradFill>
+          <a:ln>
+            <a:noFill/>
+          </a:ln>
+        </p:spPr>
+        <p:style>
+          <a:lnRef idx="2">
+            <a:schemeClr val="accent1">
+              <a:shade val="50000"/>
+            </a:schemeClr>
+          </a:lnRef>
+          <a:fillRef idx="1">
+            <a:schemeClr val="accent1"/>
+          </a:fillRef>
+          <a:effectRef idx="0">
+            <a:schemeClr val="accent1"/>
+          </a:effectRef>
+          <a:fontRef idx="minor">
+            <a:schemeClr val="lt1"/>
+          </a:fontRef>
+        </p:style>
+        <p:txBody>
+          <a:bodyPr rtlCol="0" anchor="ctr"/>
+          <a:lstStyle/>
+          <a:p>
+            <a:pPr algn="ctr"/>
+            <a:endParaRPr lang="en-US" dirty="0"/>
+          </a:p>
+        </p:txBody>
+      </p:sp>
       <p:sp>
         <p:nvSpPr>
           <p:cNvPr id="2" name="Title 1">
             <a:extLst>
               <a:ext uri="{FF2B5EF4-FFF2-40B4-BE49-F238E27FC236}">
-                <a16:creationId xmlns:a16="http://schemas.microsoft.com/office/drawing/2014/main" id="{0E9721CE-7FDB-6F1E-862D-17EEEB49DF9B}"/>
+                <a16:creationId xmlns:a16="http://schemas.microsoft.com/office/drawing/2014/main" id="{A8B4F316-66AE-96F3-5B49-868141F72C72}"/>
               </a:ext>
             </a:extLst>
           </p:cNvPr>
@@ -19382,14 +20422,26 @@
             <p:ph type="title"/>
           </p:nvPr>
         </p:nvSpPr>
-        <p:spPr/>
+        <p:spPr>
+          <a:xfrm>
+            <a:off x="748475" y="2655150"/>
+            <a:ext cx="2101666" cy="879468"/>
+          </a:xfrm>
+        </p:spPr>
         <p:txBody>
-          <a:bodyPr/>
+          <a:bodyPr anchor="b">
+            <a:normAutofit/>
+          </a:bodyPr>
           <a:lstStyle/>
           <a:p>
+            <a:pPr algn="r"/>
             <a:r>
-              <a:rPr lang="en-US" dirty="0"/>
-              <a:t>Copilot</a:t>
+              <a:rPr lang="en-US" sz="4000" dirty="0">
+                <a:solidFill>
+                  <a:srgbClr val="FFFFFF"/>
+                </a:solidFill>
+              </a:rPr>
+              <a:t>CoPilot</a:t>
             </a:r>
           </a:p>
         </p:txBody>
@@ -19399,7 +20451,7 @@
           <p:cNvPr id="3" name="Content Placeholder 2">
             <a:extLst>
               <a:ext uri="{FF2B5EF4-FFF2-40B4-BE49-F238E27FC236}">
-                <a16:creationId xmlns:a16="http://schemas.microsoft.com/office/drawing/2014/main" id="{355AB5C8-28F5-9043-0482-85B2C28C3504}"/>
+                <a16:creationId xmlns:a16="http://schemas.microsoft.com/office/drawing/2014/main" id="{27033F78-12A5-C599-2958-D2A9138E70D2}"/>
               </a:ext>
             </a:extLst>
           </p:cNvPr>
@@ -19410,19 +20462,142 @@
             <p:ph idx="1"/>
           </p:nvPr>
         </p:nvSpPr>
-        <p:spPr/>
+        <p:spPr>
+          <a:xfrm>
+            <a:off x="4377019" y="10138"/>
+            <a:ext cx="7490010" cy="6726838"/>
+          </a:xfrm>
+        </p:spPr>
         <p:txBody>
-          <a:bodyPr/>
+          <a:bodyPr anchor="ctr">
+            <a:normAutofit fontScale="92500" lnSpcReduction="20000"/>
+          </a:bodyPr>
           <a:lstStyle/>
           <a:p>
-            <a:endParaRPr lang="en-US" dirty="0"/>
+            <a:r>
+              <a:rPr lang="en-US" sz="2000" dirty="0"/>
+              <a:t>Algorithm Selection</a:t>
+            </a:r>
+          </a:p>
+          <a:p>
+            <a:pPr lvl="1"/>
+            <a:r>
+              <a:rPr lang="en-US" sz="1800" dirty="0"/>
+              <a:t>Use a one way hashing algorithm such as Argon2id, with a unique random salt is the best way to store the passwords rather then a reversible encryption. </a:t>
+            </a:r>
+          </a:p>
+          <a:p>
+            <a:pPr lvl="1"/>
+            <a:r>
+              <a:rPr lang="en-US" sz="1800" dirty="0"/>
+              <a:t>This is the best choice of algorithm for the prompt, it is both very fast and highly secure.</a:t>
+            </a:r>
+            <a:endParaRPr lang="en-US" sz="1050" dirty="0"/>
+          </a:p>
+          <a:p>
+            <a:r>
+              <a:rPr lang="en-US" sz="2000" dirty="0"/>
+              <a:t>Optimization </a:t>
+            </a:r>
+          </a:p>
+          <a:p>
+            <a:pPr lvl="1"/>
+            <a:r>
+              <a:rPr lang="en-US" sz="1800" dirty="0"/>
+              <a:t>AES-256-GCM is the primary choice for encryption of large streams of data.</a:t>
+            </a:r>
+            <a:endParaRPr lang="en-US" sz="1200" dirty="0"/>
+          </a:p>
+          <a:p>
+            <a:pPr lvl="1"/>
+            <a:r>
+              <a:rPr lang="en-US" sz="1800" dirty="0"/>
+              <a:t>If the limited hardware does not include AES acceleration, the fallback algorithm of choice is ChaCha20-Poly1305 which is significantly faster then AES when it doesn’t have ideal hardware. </a:t>
+            </a:r>
+          </a:p>
+          <a:p>
+            <a:pPr lvl="1"/>
+            <a:r>
+              <a:rPr lang="en-US" sz="1800" dirty="0"/>
+              <a:t>Either of these encryption algorithms will be able to meet the requirements outlined by the prompt.</a:t>
+            </a:r>
+          </a:p>
+          <a:p>
+            <a:r>
+              <a:rPr lang="en-US" sz="2000" dirty="0"/>
+              <a:t>Complexity</a:t>
+            </a:r>
+          </a:p>
+          <a:p>
+            <a:pPr lvl="1"/>
+            <a:r>
+              <a:rPr lang="en-US" sz="1600" dirty="0"/>
+              <a:t>Constant time:</a:t>
+            </a:r>
+          </a:p>
+          <a:p>
+            <a:pPr lvl="2"/>
+            <a:r>
+              <a:rPr lang="en-US" sz="1700" dirty="0"/>
+              <a:t>SHA-256 Hashing was the recommended encryption to use for a constant time algorithm.</a:t>
+            </a:r>
+          </a:p>
+          <a:p>
+            <a:pPr lvl="1"/>
+            <a:r>
+              <a:rPr lang="en-US" sz="1600" dirty="0"/>
+              <a:t>Logarithmic time:</a:t>
+            </a:r>
+          </a:p>
+          <a:p>
+            <a:pPr lvl="2"/>
+            <a:r>
+              <a:rPr lang="en-US" sz="1700" dirty="0"/>
+              <a:t>The license plate must first be converted into a base-36 integer and then used in modular exponentiation to best encrypt it in logarithmic time.</a:t>
+            </a:r>
+            <a:endParaRPr lang="en-US" sz="1000" dirty="0"/>
+          </a:p>
+          <a:p>
+            <a:r>
+              <a:rPr lang="en-US" sz="2000" dirty="0"/>
+              <a:t>Security Analysis</a:t>
+            </a:r>
+          </a:p>
+          <a:p>
+            <a:pPr lvl="1"/>
+            <a:r>
+              <a:rPr lang="en-US" sz="1600" dirty="0"/>
+              <a:t>Collision resistance → use a strong hash like SHA-3-512</a:t>
+            </a:r>
+          </a:p>
+          <a:p>
+            <a:pPr lvl="1"/>
+            <a:r>
+              <a:rPr lang="en-US" sz="1600" dirty="0"/>
+              <a:t>Slow computation → use a memory-hard KDF like Argon2id</a:t>
+            </a:r>
+          </a:p>
+          <a:p>
+            <a:pPr lvl="1"/>
+            <a:r>
+              <a:rPr lang="en-US" sz="1600" dirty="0"/>
+              <a:t>Tamper detection → chain hashes like a blockchain and use of a merkle tree</a:t>
+            </a:r>
+          </a:p>
+          <a:p>
+            <a:pPr lvl="1"/>
+            <a:r>
+              <a:rPr lang="en-US" sz="1600" dirty="0"/>
+              <a:t>Use a layered Argon2id + SHA-3-512 + Hash Chain + Merkle tree to best ensure security</a:t>
+            </a:r>
+            <a:endParaRPr lang="en-US" sz="2100" dirty="0"/>
           </a:p>
         </p:txBody>
       </p:sp>
     </p:spTree>
     <p:extLst>
       <p:ext uri="{BB962C8B-B14F-4D97-AF65-F5344CB8AC3E}">
-        <p14:creationId xmlns:p14="http://schemas.microsoft.com/office/powerpoint/2010/main" val="3330183413"/>
+        <p14:creationId xmlns:p14="http://schemas.microsoft.com/office/powerpoint/2010/main" val="3932995078"/>
       </p:ext>
     </p:extLst>
   </p:cSld>

</xml_diff>